<commit_message>
Banrisul: slide 19 mostra a arquitetura testada (k6 + microsservicos + EDB VM)
Substitui os cards textuais por um diagrama: k6 -> cluster Red Hat
OpenShift Virtualization (8 microsservicos + banco EDB em VM) e a pegada
224 cores x86 -> 8 IFLs.

Co-Authored-By: Claude Opus 4.8 <noreply@anthropic.com>
</commit_message>
<xml_diff>
--- a/banrisul-linuxone-2026/Banrisul-LinuxONE-2026.pptx
+++ b/banrisul-linuxone-2026/Banrisul-LinuxONE-2026.pptx
@@ -11550,8 +11550,8 @@
         </p:nvSpPr>
         <p:spPr>
           <a:xfrm>
-            <a:off x="822960" y="1097280"/>
-            <a:ext cx="10607040" cy="731520"/>
+            <a:off x="822960" y="960120"/>
+            <a:ext cx="10789920" cy="640080"/>
           </a:xfrm>
           <a:prstGeom prst="rect">
             <a:avLst/>
@@ -11567,7 +11567,7 @@
               <a:buNone/>
             </a:pPr>
             <a:r>
-              <a:rPr lang="en-US" sz="3200" dirty="0">
+              <a:rPr lang="en-US" sz="3000" dirty="0">
                 <a:solidFill>
                   <a:srgbClr val="161616"/>
                 </a:solidFill>
@@ -11581,7 +11581,7 @@
               <a:buNone/>
             </a:pPr>
             <a:r>
-              <a:rPr lang="en-US" sz="3200" dirty="0">
+              <a:rPr lang="en-US" sz="3000" dirty="0">
                 <a:solidFill>
                   <a:srgbClr val="0F62FE"/>
                 </a:solidFill>
@@ -11591,24 +11591,119 @@
               </a:rPr>
               <a:t>LinuxONE</a:t>
             </a:r>
-            <a:endParaRPr lang="en-US" sz="3200" dirty="0"/>
-          </a:p>
-        </p:txBody>
-      </p:sp>
-      <p:sp>
-        <p:nvSpPr>
-          <p:cNvPr id="5" name="Shape 3"/>
-          <p:cNvSpPr/>
-          <p:nvPr/>
-        </p:nvSpPr>
-        <p:spPr>
-          <a:xfrm>
-            <a:off x="822960" y="2377440"/>
-            <a:ext cx="4754880" cy="3108960"/>
-          </a:xfrm>
-          <a:prstGeom prst="roundRect">
-            <a:avLst>
-              <a:gd name="adj" fmla="val 2353"/>
+            <a:endParaRPr lang="en-US" sz="3000" dirty="0"/>
+          </a:p>
+        </p:txBody>
+      </p:sp>
+      <p:sp>
+        <p:nvSpPr>
+          <p:cNvPr id="5" name="Text 3"/>
+          <p:cNvSpPr/>
+          <p:nvPr/>
+        </p:nvSpPr>
+        <p:spPr>
+          <a:xfrm>
+            <a:off x="822960" y="1691640"/>
+            <a:ext cx="10607040" cy="320040"/>
+          </a:xfrm>
+          <a:prstGeom prst="rect">
+            <a:avLst/>
+          </a:prstGeom>
+          <a:noFill/>
+          <a:ln/>
+        </p:spPr>
+        <p:txBody>
+          <a:bodyPr wrap="square" lIns="0" tIns="0" rIns="0" bIns="0" rtlCol="0" anchor="ctr"/>
+          <a:lstStyle/>
+          <a:p>
+            <a:pPr indent="0" marL="0">
+              <a:buNone/>
+            </a:pPr>
+            <a:r>
+              <a:rPr lang="en-US" sz="1300" dirty="0">
+                <a:solidFill>
+                  <a:srgbClr val="525252"/>
+                </a:solidFill>
+                <a:latin typeface="IBM Plex Sans" pitchFamily="34" charset="0"/>
+                <a:ea typeface="IBM Plex Sans" pitchFamily="34" charset="-122"/>
+                <a:cs typeface="IBM Plex Sans" pitchFamily="34" charset="-120"/>
+              </a:rPr>
+              <a:t>App bancária </a:t>
+            </a:r>
+            <a:pPr indent="0" marL="0">
+              <a:buNone/>
+            </a:pPr>
+            <a:r>
+              <a:rPr lang="en-US" sz="1300" b="1" dirty="0">
+                <a:solidFill>
+                  <a:srgbClr val="161616"/>
+                </a:solidFill>
+                <a:latin typeface="IBM Plex Sans" pitchFamily="34" charset="0"/>
+                <a:ea typeface="IBM Plex Sans" pitchFamily="34" charset="-122"/>
+                <a:cs typeface="IBM Plex Sans" pitchFamily="34" charset="-120"/>
+              </a:rPr>
+              <a:t>EnterpriseDB</a:t>
+            </a:r>
+            <a:pPr indent="0" marL="0">
+              <a:buNone/>
+            </a:pPr>
+            <a:r>
+              <a:rPr lang="en-US" sz="1300" dirty="0">
+                <a:solidFill>
+                  <a:srgbClr val="525252"/>
+                </a:solidFill>
+                <a:latin typeface="IBM Plex Sans" pitchFamily="34" charset="0"/>
+                <a:ea typeface="IBM Plex Sans" pitchFamily="34" charset="-122"/>
+                <a:cs typeface="IBM Plex Sans" pitchFamily="34" charset="-120"/>
+              </a:rPr>
+              <a:t> sob carga </a:t>
+            </a:r>
+            <a:pPr indent="0" marL="0">
+              <a:buNone/>
+            </a:pPr>
+            <a:r>
+              <a:rPr lang="en-US" sz="1300" b="1" dirty="0">
+                <a:solidFill>
+                  <a:srgbClr val="161616"/>
+                </a:solidFill>
+                <a:latin typeface="IBM Plex Sans" pitchFamily="34" charset="0"/>
+                <a:ea typeface="IBM Plex Sans" pitchFamily="34" charset="-122"/>
+                <a:cs typeface="IBM Plex Sans" pitchFamily="34" charset="-120"/>
+              </a:rPr>
+              <a:t>k6</a:t>
+            </a:r>
+            <a:pPr indent="0" marL="0">
+              <a:buNone/>
+            </a:pPr>
+            <a:r>
+              <a:rPr lang="en-US" sz="1300" dirty="0">
+                <a:solidFill>
+                  <a:srgbClr val="525252"/>
+                </a:solidFill>
+                <a:latin typeface="IBM Plex Sans" pitchFamily="34" charset="0"/>
+                <a:ea typeface="IBM Plex Sans" pitchFamily="34" charset="-122"/>
+                <a:cs typeface="IBM Plex Sans" pitchFamily="34" charset="-120"/>
+              </a:rPr>
+              <a:t> — exatamente a mesma arquitetura nos dois ambientes:</a:t>
+            </a:r>
+            <a:endParaRPr lang="en-US" sz="1300" dirty="0"/>
+          </a:p>
+        </p:txBody>
+      </p:sp>
+      <p:sp>
+        <p:nvSpPr>
+          <p:cNvPr id="6" name="Shape 4"/>
+          <p:cNvSpPr/>
+          <p:nvPr/>
+        </p:nvSpPr>
+        <p:spPr>
+          <a:xfrm>
+            <a:off x="822960" y="2240280"/>
+            <a:ext cx="1371600" cy="1965960"/>
+          </a:xfrm>
+          <a:prstGeom prst="roundRect">
+            <a:avLst>
+              <a:gd name="adj" fmla="val 5333"/>
             </a:avLst>
           </a:prstGeom>
           <a:solidFill>
@@ -11624,14 +11719,14 @@
       </p:sp>
       <p:sp>
         <p:nvSpPr>
-          <p:cNvPr id="6" name="Text 4"/>
-          <p:cNvSpPr/>
-          <p:nvPr/>
-        </p:nvSpPr>
-        <p:spPr>
-          <a:xfrm>
-            <a:off x="1188720" y="2651760"/>
-            <a:ext cx="4023360" cy="274320"/>
+          <p:cNvPr id="7" name="Text 5"/>
+          <p:cNvSpPr/>
+          <p:nvPr/>
+        </p:nvSpPr>
+        <p:spPr>
+          <a:xfrm>
+            <a:off x="822960" y="2468880"/>
+            <a:ext cx="1371600" cy="228600"/>
           </a:xfrm>
           <a:prstGeom prst="rect">
             <a:avLst/>
@@ -11643,11 +11738,11 @@
           <a:bodyPr wrap="square" lIns="0" tIns="0" rIns="0" bIns="0" rtlCol="0" anchor="ctr"/>
           <a:lstStyle/>
           <a:p>
-            <a:pPr indent="0" marL="0">
-              <a:buNone/>
-            </a:pPr>
-            <a:r>
-              <a:rPr lang="en-US" sz="1100" spc="100" kern="0" dirty="0">
+            <a:pPr algn="ctr" indent="0" marL="0">
+              <a:buNone/>
+            </a:pPr>
+            <a:r>
+              <a:rPr lang="en-US" sz="950" spc="100" kern="0" dirty="0">
                 <a:solidFill>
                   <a:srgbClr val="525252"/>
                 </a:solidFill>
@@ -11655,7 +11750,339 @@
                 <a:ea typeface="IBM Plex Mono" pitchFamily="34" charset="-122"/>
                 <a:cs typeface="IBM Plex Mono" pitchFamily="34" charset="-120"/>
               </a:rPr>
-              <a:t>PONTO DE PARTIDA · X86</a:t>
+              <a:t>CARGA</a:t>
+            </a:r>
+            <a:endParaRPr lang="en-US" sz="950" dirty="0"/>
+          </a:p>
+        </p:txBody>
+      </p:sp>
+      <p:sp>
+        <p:nvSpPr>
+          <p:cNvPr id="8" name="Shape 6"/>
+          <p:cNvSpPr/>
+          <p:nvPr/>
+        </p:nvSpPr>
+        <p:spPr>
+          <a:xfrm>
+            <a:off x="1069848" y="2971800"/>
+            <a:ext cx="274320" cy="274320"/>
+          </a:xfrm>
+          <a:prstGeom prst="roundRect">
+            <a:avLst>
+              <a:gd name="adj" fmla="val 16667"/>
+            </a:avLst>
+          </a:prstGeom>
+          <a:solidFill>
+            <a:srgbClr val="0F62FE"/>
+          </a:solidFill>
+          <a:ln/>
+        </p:spPr>
+      </p:sp>
+      <p:sp>
+        <p:nvSpPr>
+          <p:cNvPr id="9" name="Text 7"/>
+          <p:cNvSpPr/>
+          <p:nvPr/>
+        </p:nvSpPr>
+        <p:spPr>
+          <a:xfrm>
+            <a:off x="1069848" y="2971800"/>
+            <a:ext cx="274320" cy="274320"/>
+          </a:xfrm>
+          <a:prstGeom prst="rect">
+            <a:avLst/>
+          </a:prstGeom>
+          <a:noFill/>
+          <a:ln/>
+        </p:spPr>
+        <p:txBody>
+          <a:bodyPr wrap="square" lIns="0" tIns="0" rIns="0" bIns="0" rtlCol="0" anchor="ctr"/>
+          <a:lstStyle/>
+          <a:p>
+            <a:pPr algn="ctr" indent="0" marL="0">
+              <a:buNone/>
+            </a:pPr>
+            <a:r>
+              <a:rPr lang="en-US" sz="800" b="1" dirty="0">
+                <a:solidFill>
+                  <a:srgbClr val="FFFFFF"/>
+                </a:solidFill>
+                <a:latin typeface="IBM Plex Mono" pitchFamily="34" charset="0"/>
+                <a:ea typeface="IBM Plex Mono" pitchFamily="34" charset="-122"/>
+                <a:cs typeface="IBM Plex Mono" pitchFamily="34" charset="-120"/>
+              </a:rPr>
+              <a:t>k6</a:t>
+            </a:r>
+            <a:endParaRPr lang="en-US" sz="800" dirty="0"/>
+          </a:p>
+        </p:txBody>
+      </p:sp>
+      <p:sp>
+        <p:nvSpPr>
+          <p:cNvPr id="10" name="Shape 8"/>
+          <p:cNvSpPr/>
+          <p:nvPr/>
+        </p:nvSpPr>
+        <p:spPr>
+          <a:xfrm>
+            <a:off x="1380744" y="2971800"/>
+            <a:ext cx="274320" cy="274320"/>
+          </a:xfrm>
+          <a:prstGeom prst="roundRect">
+            <a:avLst>
+              <a:gd name="adj" fmla="val 16667"/>
+            </a:avLst>
+          </a:prstGeom>
+          <a:solidFill>
+            <a:srgbClr val="0F62FE"/>
+          </a:solidFill>
+          <a:ln/>
+        </p:spPr>
+      </p:sp>
+      <p:sp>
+        <p:nvSpPr>
+          <p:cNvPr id="11" name="Text 9"/>
+          <p:cNvSpPr/>
+          <p:nvPr/>
+        </p:nvSpPr>
+        <p:spPr>
+          <a:xfrm>
+            <a:off x="1380744" y="2971800"/>
+            <a:ext cx="274320" cy="274320"/>
+          </a:xfrm>
+          <a:prstGeom prst="rect">
+            <a:avLst/>
+          </a:prstGeom>
+          <a:noFill/>
+          <a:ln/>
+        </p:spPr>
+        <p:txBody>
+          <a:bodyPr wrap="square" lIns="0" tIns="0" rIns="0" bIns="0" rtlCol="0" anchor="ctr"/>
+          <a:lstStyle/>
+          <a:p>
+            <a:pPr algn="ctr" indent="0" marL="0">
+              <a:buNone/>
+            </a:pPr>
+            <a:r>
+              <a:rPr lang="en-US" sz="800" b="1" dirty="0">
+                <a:solidFill>
+                  <a:srgbClr val="FFFFFF"/>
+                </a:solidFill>
+                <a:latin typeface="IBM Plex Mono" pitchFamily="34" charset="0"/>
+                <a:ea typeface="IBM Plex Mono" pitchFamily="34" charset="-122"/>
+                <a:cs typeface="IBM Plex Mono" pitchFamily="34" charset="-120"/>
+              </a:rPr>
+              <a:t>k6</a:t>
+            </a:r>
+            <a:endParaRPr lang="en-US" sz="800" dirty="0"/>
+          </a:p>
+        </p:txBody>
+      </p:sp>
+      <p:sp>
+        <p:nvSpPr>
+          <p:cNvPr id="12" name="Shape 10"/>
+          <p:cNvSpPr/>
+          <p:nvPr/>
+        </p:nvSpPr>
+        <p:spPr>
+          <a:xfrm>
+            <a:off x="1691640" y="2971800"/>
+            <a:ext cx="274320" cy="274320"/>
+          </a:xfrm>
+          <a:prstGeom prst="roundRect">
+            <a:avLst>
+              <a:gd name="adj" fmla="val 16667"/>
+            </a:avLst>
+          </a:prstGeom>
+          <a:solidFill>
+            <a:srgbClr val="0F62FE"/>
+          </a:solidFill>
+          <a:ln/>
+        </p:spPr>
+      </p:sp>
+      <p:sp>
+        <p:nvSpPr>
+          <p:cNvPr id="13" name="Text 11"/>
+          <p:cNvSpPr/>
+          <p:nvPr/>
+        </p:nvSpPr>
+        <p:spPr>
+          <a:xfrm>
+            <a:off x="1691640" y="2971800"/>
+            <a:ext cx="274320" cy="274320"/>
+          </a:xfrm>
+          <a:prstGeom prst="rect">
+            <a:avLst/>
+          </a:prstGeom>
+          <a:noFill/>
+          <a:ln/>
+        </p:spPr>
+        <p:txBody>
+          <a:bodyPr wrap="square" lIns="0" tIns="0" rIns="0" bIns="0" rtlCol="0" anchor="ctr"/>
+          <a:lstStyle/>
+          <a:p>
+            <a:pPr algn="ctr" indent="0" marL="0">
+              <a:buNone/>
+            </a:pPr>
+            <a:r>
+              <a:rPr lang="en-US" sz="800" b="1" dirty="0">
+                <a:solidFill>
+                  <a:srgbClr val="FFFFFF"/>
+                </a:solidFill>
+                <a:latin typeface="IBM Plex Mono" pitchFamily="34" charset="0"/>
+                <a:ea typeface="IBM Plex Mono" pitchFamily="34" charset="-122"/>
+                <a:cs typeface="IBM Plex Mono" pitchFamily="34" charset="-120"/>
+              </a:rPr>
+              <a:t>k6</a:t>
+            </a:r>
+            <a:endParaRPr lang="en-US" sz="800" dirty="0"/>
+          </a:p>
+        </p:txBody>
+      </p:sp>
+      <p:sp>
+        <p:nvSpPr>
+          <p:cNvPr id="14" name="Text 12"/>
+          <p:cNvSpPr/>
+          <p:nvPr/>
+        </p:nvSpPr>
+        <p:spPr>
+          <a:xfrm>
+            <a:off x="822960" y="3474720"/>
+            <a:ext cx="1371600" cy="228600"/>
+          </a:xfrm>
+          <a:prstGeom prst="rect">
+            <a:avLst/>
+          </a:prstGeom>
+          <a:noFill/>
+          <a:ln/>
+        </p:spPr>
+        <p:txBody>
+          <a:bodyPr wrap="square" lIns="0" tIns="0" rIns="0" bIns="0" rtlCol="0" anchor="ctr"/>
+          <a:lstStyle/>
+          <a:p>
+            <a:pPr algn="ctr" indent="0" marL="0">
+              <a:buNone/>
+            </a:pPr>
+            <a:r>
+              <a:rPr lang="en-US" sz="850" dirty="0">
+                <a:solidFill>
+                  <a:srgbClr val="525252"/>
+                </a:solidFill>
+                <a:latin typeface="IBM Plex Mono" pitchFamily="34" charset="0"/>
+                <a:ea typeface="IBM Plex Mono" pitchFamily="34" charset="-122"/>
+                <a:cs typeface="IBM Plex Mono" pitchFamily="34" charset="-120"/>
+              </a:rPr>
+              <a:t>test driver</a:t>
+            </a:r>
+            <a:endParaRPr lang="en-US" sz="850" dirty="0"/>
+          </a:p>
+        </p:txBody>
+      </p:sp>
+      <p:sp>
+        <p:nvSpPr>
+          <p:cNvPr id="15" name="Shape 13"/>
+          <p:cNvSpPr/>
+          <p:nvPr/>
+        </p:nvSpPr>
+        <p:spPr>
+          <a:xfrm>
+            <a:off x="2267712" y="3223260"/>
+            <a:ext cx="365760" cy="0"/>
+          </a:xfrm>
+          <a:prstGeom prst="line">
+            <a:avLst/>
+          </a:prstGeom>
+          <a:noFill/>
+          <a:ln w="31750">
+            <a:solidFill>
+              <a:srgbClr val="0F62FE"/>
+            </a:solidFill>
+            <a:prstDash val="solid"/>
+            <a:tailEnd type="triangle"/>
+          </a:ln>
+        </p:spPr>
+      </p:sp>
+      <p:sp>
+        <p:nvSpPr>
+          <p:cNvPr id="16" name="Shape 14"/>
+          <p:cNvSpPr/>
+          <p:nvPr/>
+        </p:nvSpPr>
+        <p:spPr>
+          <a:xfrm>
+            <a:off x="2761488" y="2240280"/>
+            <a:ext cx="8577072" cy="1965960"/>
+          </a:xfrm>
+          <a:prstGeom prst="roundRect">
+            <a:avLst>
+              <a:gd name="adj" fmla="val 4651"/>
+            </a:avLst>
+          </a:prstGeom>
+          <a:solidFill>
+            <a:srgbClr val="F2F6FF"/>
+          </a:solidFill>
+          <a:ln w="15875">
+            <a:solidFill>
+              <a:srgbClr val="9DBBFF"/>
+            </a:solidFill>
+            <a:prstDash val="solid"/>
+          </a:ln>
+        </p:spPr>
+      </p:sp>
+      <p:sp>
+        <p:nvSpPr>
+          <p:cNvPr id="17" name="Shape 15"/>
+          <p:cNvSpPr/>
+          <p:nvPr/>
+        </p:nvSpPr>
+        <p:spPr>
+          <a:xfrm>
+            <a:off x="2990088" y="2514600"/>
+            <a:ext cx="118872" cy="118872"/>
+          </a:xfrm>
+          <a:prstGeom prst="rect">
+            <a:avLst/>
+          </a:prstGeom>
+          <a:solidFill>
+            <a:srgbClr val="EE0000"/>
+          </a:solidFill>
+          <a:ln/>
+        </p:spPr>
+      </p:sp>
+      <p:sp>
+        <p:nvSpPr>
+          <p:cNvPr id="18" name="Text 16"/>
+          <p:cNvSpPr/>
+          <p:nvPr/>
+        </p:nvSpPr>
+        <p:spPr>
+          <a:xfrm>
+            <a:off x="3182112" y="2404872"/>
+            <a:ext cx="7936992" cy="274320"/>
+          </a:xfrm>
+          <a:prstGeom prst="rect">
+            <a:avLst/>
+          </a:prstGeom>
+          <a:noFill/>
+          <a:ln/>
+        </p:spPr>
+        <p:txBody>
+          <a:bodyPr wrap="square" lIns="0" tIns="0" rIns="0" bIns="0" rtlCol="0" anchor="ctr"/>
+          <a:lstStyle/>
+          <a:p>
+            <a:pPr indent="0" marL="0">
+              <a:buNone/>
+            </a:pPr>
+            <a:r>
+              <a:rPr lang="en-US" sz="1100" dirty="0">
+                <a:solidFill>
+                  <a:srgbClr val="0F62FE"/>
+                </a:solidFill>
+                <a:latin typeface="IBM Plex Mono" pitchFamily="34" charset="0"/>
+                <a:ea typeface="IBM Plex Mono" pitchFamily="34" charset="-122"/>
+                <a:cs typeface="IBM Plex Mono" pitchFamily="34" charset="-120"/>
+              </a:rPr>
+              <a:t>Red Hat OpenShift Virtualization</a:t>
             </a:r>
             <a:endParaRPr lang="en-US" sz="1100" dirty="0"/>
           </a:p>
@@ -11663,261 +12090,22 @@
       </p:sp>
       <p:sp>
         <p:nvSpPr>
-          <p:cNvPr id="7" name="Text 5"/>
-          <p:cNvSpPr/>
-          <p:nvPr/>
-        </p:nvSpPr>
-        <p:spPr>
-          <a:xfrm>
-            <a:off x="1188720" y="2944368"/>
-            <a:ext cx="4023360" cy="822960"/>
-          </a:xfrm>
-          <a:prstGeom prst="rect">
-            <a:avLst/>
-          </a:prstGeom>
-          <a:noFill/>
-          <a:ln/>
-        </p:spPr>
-        <p:txBody>
-          <a:bodyPr wrap="square" lIns="0" tIns="0" rIns="0" bIns="0" rtlCol="0" anchor="ctr"/>
-          <a:lstStyle/>
-          <a:p>
-            <a:pPr indent="0" marL="0">
-              <a:buNone/>
-            </a:pPr>
-            <a:r>
-              <a:rPr lang="en-US" sz="4600" dirty="0">
-                <a:solidFill>
-                  <a:srgbClr val="8D8D8D"/>
-                </a:solidFill>
-                <a:latin typeface="IBM Plex Sans" pitchFamily="34" charset="0"/>
-                <a:ea typeface="IBM Plex Sans" pitchFamily="34" charset="-122"/>
-                <a:cs typeface="IBM Plex Sans" pitchFamily="34" charset="-120"/>
-              </a:rPr>
-              <a:t>224</a:t>
-            </a:r>
-            <a:pPr indent="0" marL="0">
-              <a:buNone/>
-            </a:pPr>
-            <a:r>
-              <a:rPr lang="en-US" sz="1800" dirty="0">
-                <a:solidFill>
-                  <a:srgbClr val="525252"/>
-                </a:solidFill>
-                <a:latin typeface="IBM Plex Sans" pitchFamily="34" charset="0"/>
-                <a:ea typeface="IBM Plex Sans" pitchFamily="34" charset="-122"/>
-                <a:cs typeface="IBM Plex Sans" pitchFamily="34" charset="-120"/>
-              </a:rPr>
-              <a:t> cores</a:t>
-            </a:r>
-            <a:endParaRPr lang="en-US" sz="4600" dirty="0"/>
-          </a:p>
-        </p:txBody>
-      </p:sp>
-      <p:sp>
-        <p:nvSpPr>
-          <p:cNvPr id="8" name="Shape 6"/>
-          <p:cNvSpPr/>
-          <p:nvPr/>
-        </p:nvSpPr>
-        <p:spPr>
-          <a:xfrm>
-            <a:off x="1234440" y="4187952"/>
-            <a:ext cx="91440" cy="91440"/>
-          </a:xfrm>
-          <a:prstGeom prst="ellipse">
-            <a:avLst/>
-          </a:prstGeom>
-          <a:solidFill>
-            <a:srgbClr val="0F62FE"/>
-          </a:solidFill>
-          <a:ln/>
-        </p:spPr>
-      </p:sp>
-      <p:sp>
-        <p:nvSpPr>
-          <p:cNvPr id="9" name="Text 7"/>
-          <p:cNvSpPr/>
-          <p:nvPr/>
-        </p:nvSpPr>
-        <p:spPr>
-          <a:xfrm>
-            <a:off x="1463040" y="4114800"/>
-            <a:ext cx="3749040" cy="384048"/>
-          </a:xfrm>
-          <a:prstGeom prst="rect">
-            <a:avLst/>
-          </a:prstGeom>
-          <a:noFill/>
-          <a:ln/>
-        </p:spPr>
-        <p:txBody>
-          <a:bodyPr wrap="square" lIns="0" tIns="0" rIns="0" bIns="0" rtlCol="0" anchor="t"/>
-          <a:lstStyle/>
-          <a:p>
-            <a:pPr indent="0" marL="0">
-              <a:lnSpc>
-                <a:spcPct val="110000"/>
-              </a:lnSpc>
-              <a:buNone/>
-            </a:pPr>
-            <a:r>
-              <a:rPr lang="en-US" sz="1300" dirty="0">
-                <a:solidFill>
-                  <a:srgbClr val="161616"/>
-                </a:solidFill>
-                <a:latin typeface="IBM Plex Sans" pitchFamily="34" charset="0"/>
-                <a:ea typeface="IBM Plex Sans" pitchFamily="34" charset="-122"/>
-                <a:cs typeface="IBM Plex Sans" pitchFamily="34" charset="-120"/>
-              </a:rPr>
-              <a:t>5 servidores x86</a:t>
-            </a:r>
-            <a:endParaRPr lang="en-US" sz="1300" dirty="0"/>
-          </a:p>
-        </p:txBody>
-      </p:sp>
-      <p:sp>
-        <p:nvSpPr>
-          <p:cNvPr id="10" name="Shape 8"/>
-          <p:cNvSpPr/>
-          <p:nvPr/>
-        </p:nvSpPr>
-        <p:spPr>
-          <a:xfrm>
-            <a:off x="1234440" y="4608576"/>
-            <a:ext cx="91440" cy="91440"/>
-          </a:xfrm>
-          <a:prstGeom prst="ellipse">
-            <a:avLst/>
-          </a:prstGeom>
-          <a:solidFill>
-            <a:srgbClr val="0F62FE"/>
-          </a:solidFill>
-          <a:ln/>
-        </p:spPr>
-      </p:sp>
-      <p:sp>
-        <p:nvSpPr>
-          <p:cNvPr id="11" name="Text 9"/>
-          <p:cNvSpPr/>
-          <p:nvPr/>
-        </p:nvSpPr>
-        <p:spPr>
-          <a:xfrm>
-            <a:off x="1463040" y="4535424"/>
-            <a:ext cx="3749040" cy="384048"/>
-          </a:xfrm>
-          <a:prstGeom prst="rect">
-            <a:avLst/>
-          </a:prstGeom>
-          <a:noFill/>
-          <a:ln/>
-        </p:spPr>
-        <p:txBody>
-          <a:bodyPr wrap="square" lIns="0" tIns="0" rIns="0" bIns="0" rtlCol="0" anchor="t"/>
-          <a:lstStyle/>
-          <a:p>
-            <a:pPr indent="0" marL="0">
-              <a:lnSpc>
-                <a:spcPct val="110000"/>
-              </a:lnSpc>
-              <a:buNone/>
-            </a:pPr>
-            <a:r>
-              <a:rPr lang="en-US" sz="1300" dirty="0">
-                <a:solidFill>
-                  <a:srgbClr val="161616"/>
-                </a:solidFill>
-                <a:latin typeface="IBM Plex Sans" pitchFamily="34" charset="0"/>
-                <a:ea typeface="IBM Plex Sans" pitchFamily="34" charset="-122"/>
-                <a:cs typeface="IBM Plex Sans" pitchFamily="34" charset="-120"/>
-              </a:rPr>
-              <a:t>Aplicação EnterpriseDB (EDB) containerizada</a:t>
-            </a:r>
-            <a:endParaRPr lang="en-US" sz="1300" dirty="0"/>
-          </a:p>
-        </p:txBody>
-      </p:sp>
-      <p:sp>
-        <p:nvSpPr>
-          <p:cNvPr id="12" name="Shape 10"/>
-          <p:cNvSpPr/>
-          <p:nvPr/>
-        </p:nvSpPr>
-        <p:spPr>
-          <a:xfrm>
-            <a:off x="1234440" y="5029200"/>
-            <a:ext cx="91440" cy="91440"/>
-          </a:xfrm>
-          <a:prstGeom prst="ellipse">
-            <a:avLst/>
-          </a:prstGeom>
-          <a:solidFill>
-            <a:srgbClr val="0F62FE"/>
-          </a:solidFill>
-          <a:ln/>
-        </p:spPr>
-      </p:sp>
-      <p:sp>
-        <p:nvSpPr>
-          <p:cNvPr id="13" name="Text 11"/>
-          <p:cNvSpPr/>
-          <p:nvPr/>
-        </p:nvSpPr>
-        <p:spPr>
-          <a:xfrm>
-            <a:off x="1463040" y="4956048"/>
-            <a:ext cx="3749040" cy="384048"/>
-          </a:xfrm>
-          <a:prstGeom prst="rect">
-            <a:avLst/>
-          </a:prstGeom>
-          <a:noFill/>
-          <a:ln/>
-        </p:spPr>
-        <p:txBody>
-          <a:bodyPr wrap="square" lIns="0" tIns="0" rIns="0" bIns="0" rtlCol="0" anchor="t"/>
-          <a:lstStyle/>
-          <a:p>
-            <a:pPr indent="0" marL="0">
-              <a:lnSpc>
-                <a:spcPct val="110000"/>
-              </a:lnSpc>
-              <a:buNone/>
-            </a:pPr>
-            <a:r>
-              <a:rPr lang="en-US" sz="1300" dirty="0">
-                <a:solidFill>
-                  <a:srgbClr val="161616"/>
-                </a:solidFill>
-                <a:latin typeface="IBM Plex Sans" pitchFamily="34" charset="0"/>
-                <a:ea typeface="IBM Plex Sans" pitchFamily="34" charset="-122"/>
-                <a:cs typeface="IBM Plex Sans" pitchFamily="34" charset="-120"/>
-              </a:rPr>
-              <a:t>Banco de dados em VM (VMware)</a:t>
-            </a:r>
-            <a:endParaRPr lang="en-US" sz="1300" dirty="0"/>
-          </a:p>
-        </p:txBody>
-      </p:sp>
-      <p:sp>
-        <p:nvSpPr>
-          <p:cNvPr id="14" name="Shape 12"/>
-          <p:cNvSpPr/>
-          <p:nvPr/>
-        </p:nvSpPr>
-        <p:spPr>
-          <a:xfrm>
-            <a:off x="6400800" y="2377440"/>
-            <a:ext cx="4754880" cy="3108960"/>
-          </a:xfrm>
-          <a:prstGeom prst="roundRect">
-            <a:avLst>
-              <a:gd name="adj" fmla="val 2353"/>
-            </a:avLst>
-          </a:prstGeom>
-          <a:solidFill>
-            <a:srgbClr val="F4F4F4"/>
+          <p:cNvPr id="19" name="Shape 17"/>
+          <p:cNvSpPr/>
+          <p:nvPr/>
+        </p:nvSpPr>
+        <p:spPr>
+          <a:xfrm>
+            <a:off x="2990088" y="2807208"/>
+            <a:ext cx="1920240" cy="365760"/>
+          </a:xfrm>
+          <a:prstGeom prst="roundRect">
+            <a:avLst>
+              <a:gd name="adj" fmla="val 12500"/>
+            </a:avLst>
+          </a:prstGeom>
+          <a:solidFill>
+            <a:srgbClr val="FFFFFF"/>
           </a:solidFill>
           <a:ln w="9525">
             <a:solidFill>
@@ -11929,14 +12117,14 @@
       </p:sp>
       <p:sp>
         <p:nvSpPr>
-          <p:cNvPr id="15" name="Text 13"/>
-          <p:cNvSpPr/>
-          <p:nvPr/>
-        </p:nvSpPr>
-        <p:spPr>
-          <a:xfrm>
-            <a:off x="6766560" y="2651760"/>
-            <a:ext cx="4023360" cy="274320"/>
+          <p:cNvPr id="20" name="Text 18"/>
+          <p:cNvSpPr/>
+          <p:nvPr/>
+        </p:nvSpPr>
+        <p:spPr>
+          <a:xfrm>
+            <a:off x="2990088" y="2807208"/>
+            <a:ext cx="1920240" cy="365760"/>
           </a:xfrm>
           <a:prstGeom prst="rect">
             <a:avLst/>
@@ -11948,34 +12136,61 @@
           <a:bodyPr wrap="square" lIns="0" tIns="0" rIns="0" bIns="0" rtlCol="0" anchor="ctr"/>
           <a:lstStyle/>
           <a:p>
-            <a:pPr indent="0" marL="0">
-              <a:buNone/>
-            </a:pPr>
-            <a:r>
-              <a:rPr lang="en-US" sz="1100" spc="100" kern="0" dirty="0">
-                <a:solidFill>
-                  <a:srgbClr val="525252"/>
+            <a:pPr algn="ctr" indent="0" marL="0">
+              <a:buNone/>
+            </a:pPr>
+            <a:r>
+              <a:rPr lang="en-US" sz="900" dirty="0">
+                <a:solidFill>
+                  <a:srgbClr val="161616"/>
                 </a:solidFill>
                 <a:latin typeface="IBM Plex Mono" pitchFamily="34" charset="0"/>
                 <a:ea typeface="IBM Plex Mono" pitchFamily="34" charset="-122"/>
                 <a:cs typeface="IBM Plex Mono" pitchFamily="34" charset="-120"/>
               </a:rPr>
-              <a:t>DESTINO · IBM LINUXONE</a:t>
-            </a:r>
-            <a:endParaRPr lang="en-US" sz="1100" dirty="0"/>
-          </a:p>
-        </p:txBody>
-      </p:sp>
-      <p:sp>
-        <p:nvSpPr>
-          <p:cNvPr id="16" name="Text 14"/>
-          <p:cNvSpPr/>
-          <p:nvPr/>
-        </p:nvSpPr>
-        <p:spPr>
-          <a:xfrm>
-            <a:off x="6766560" y="2944368"/>
-            <a:ext cx="4023360" cy="822960"/>
+              <a:t>mbweb</a:t>
+            </a:r>
+            <a:endParaRPr lang="en-US" sz="900" dirty="0"/>
+          </a:p>
+        </p:txBody>
+      </p:sp>
+      <p:sp>
+        <p:nvSpPr>
+          <p:cNvPr id="21" name="Shape 19"/>
+          <p:cNvSpPr/>
+          <p:nvPr/>
+        </p:nvSpPr>
+        <p:spPr>
+          <a:xfrm>
+            <a:off x="5056632" y="2807208"/>
+            <a:ext cx="1920240" cy="365760"/>
+          </a:xfrm>
+          <a:prstGeom prst="roundRect">
+            <a:avLst>
+              <a:gd name="adj" fmla="val 12500"/>
+            </a:avLst>
+          </a:prstGeom>
+          <a:solidFill>
+            <a:srgbClr val="FFFFFF"/>
+          </a:solidFill>
+          <a:ln w="9525">
+            <a:solidFill>
+              <a:srgbClr val="D0D0D0"/>
+            </a:solidFill>
+            <a:prstDash val="solid"/>
+          </a:ln>
+        </p:spPr>
+      </p:sp>
+      <p:sp>
+        <p:nvSpPr>
+          <p:cNvPr id="22" name="Text 20"/>
+          <p:cNvSpPr/>
+          <p:nvPr/>
+        </p:nvSpPr>
+        <p:spPr>
+          <a:xfrm>
+            <a:off x="5056632" y="2807208"/>
+            <a:ext cx="1920240" cy="365760"/>
           </a:xfrm>
           <a:prstGeom prst="rect">
             <a:avLst/>
@@ -11987,234 +12202,601 @@
           <a:bodyPr wrap="square" lIns="0" tIns="0" rIns="0" bIns="0" rtlCol="0" anchor="ctr"/>
           <a:lstStyle/>
           <a:p>
+            <a:pPr algn="ctr" indent="0" marL="0">
+              <a:buNone/>
+            </a:pPr>
+            <a:r>
+              <a:rPr lang="en-US" sz="900" dirty="0">
+                <a:solidFill>
+                  <a:srgbClr val="161616"/>
+                </a:solidFill>
+                <a:latin typeface="IBM Plex Mono" pitchFamily="34" charset="0"/>
+                <a:ea typeface="IBM Plex Mono" pitchFamily="34" charset="-122"/>
+                <a:cs typeface="IBM Plex Mono" pitchFamily="34" charset="-120"/>
+              </a:rPr>
+              <a:t>customer-svc</a:t>
+            </a:r>
+            <a:endParaRPr lang="en-US" sz="900" dirty="0"/>
+          </a:p>
+        </p:txBody>
+      </p:sp>
+      <p:sp>
+        <p:nvSpPr>
+          <p:cNvPr id="23" name="Shape 21"/>
+          <p:cNvSpPr/>
+          <p:nvPr/>
+        </p:nvSpPr>
+        <p:spPr>
+          <a:xfrm>
+            <a:off x="7123176" y="2807208"/>
+            <a:ext cx="1920240" cy="365760"/>
+          </a:xfrm>
+          <a:prstGeom prst="roundRect">
+            <a:avLst>
+              <a:gd name="adj" fmla="val 12500"/>
+            </a:avLst>
+          </a:prstGeom>
+          <a:solidFill>
+            <a:srgbClr val="FFFFFF"/>
+          </a:solidFill>
+          <a:ln w="9525">
+            <a:solidFill>
+              <a:srgbClr val="D0D0D0"/>
+            </a:solidFill>
+            <a:prstDash val="solid"/>
+          </a:ln>
+        </p:spPr>
+      </p:sp>
+      <p:sp>
+        <p:nvSpPr>
+          <p:cNvPr id="24" name="Text 22"/>
+          <p:cNvSpPr/>
+          <p:nvPr/>
+        </p:nvSpPr>
+        <p:spPr>
+          <a:xfrm>
+            <a:off x="7123176" y="2807208"/>
+            <a:ext cx="1920240" cy="365760"/>
+          </a:xfrm>
+          <a:prstGeom prst="rect">
+            <a:avLst/>
+          </a:prstGeom>
+          <a:noFill/>
+          <a:ln/>
+        </p:spPr>
+        <p:txBody>
+          <a:bodyPr wrap="square" lIns="0" tIns="0" rIns="0" bIns="0" rtlCol="0" anchor="ctr"/>
+          <a:lstStyle/>
+          <a:p>
+            <a:pPr algn="ctr" indent="0" marL="0">
+              <a:buNone/>
+            </a:pPr>
+            <a:r>
+              <a:rPr lang="en-US" sz="900" dirty="0">
+                <a:solidFill>
+                  <a:srgbClr val="161616"/>
+                </a:solidFill>
+                <a:latin typeface="IBM Plex Mono" pitchFamily="34" charset="0"/>
+                <a:ea typeface="IBM Plex Mono" pitchFamily="34" charset="-122"/>
+                <a:cs typeface="IBM Plex Mono" pitchFamily="34" charset="-120"/>
+              </a:rPr>
+              <a:t>login</a:t>
+            </a:r>
+            <a:endParaRPr lang="en-US" sz="900" dirty="0"/>
+          </a:p>
+        </p:txBody>
+      </p:sp>
+      <p:sp>
+        <p:nvSpPr>
+          <p:cNvPr id="25" name="Shape 23"/>
+          <p:cNvSpPr/>
+          <p:nvPr/>
+        </p:nvSpPr>
+        <p:spPr>
+          <a:xfrm>
+            <a:off x="9189720" y="2807208"/>
+            <a:ext cx="1920240" cy="365760"/>
+          </a:xfrm>
+          <a:prstGeom prst="roundRect">
+            <a:avLst>
+              <a:gd name="adj" fmla="val 12500"/>
+            </a:avLst>
+          </a:prstGeom>
+          <a:solidFill>
+            <a:srgbClr val="FFFFFF"/>
+          </a:solidFill>
+          <a:ln w="9525">
+            <a:solidFill>
+              <a:srgbClr val="D0D0D0"/>
+            </a:solidFill>
+            <a:prstDash val="solid"/>
+          </a:ln>
+        </p:spPr>
+      </p:sp>
+      <p:sp>
+        <p:nvSpPr>
+          <p:cNvPr id="26" name="Text 24"/>
+          <p:cNvSpPr/>
+          <p:nvPr/>
+        </p:nvSpPr>
+        <p:spPr>
+          <a:xfrm>
+            <a:off x="9189720" y="2807208"/>
+            <a:ext cx="1920240" cy="365760"/>
+          </a:xfrm>
+          <a:prstGeom prst="rect">
+            <a:avLst/>
+          </a:prstGeom>
+          <a:noFill/>
+          <a:ln/>
+        </p:spPr>
+        <p:txBody>
+          <a:bodyPr wrap="square" lIns="0" tIns="0" rIns="0" bIns="0" rtlCol="0" anchor="ctr"/>
+          <a:lstStyle/>
+          <a:p>
+            <a:pPr algn="ctr" indent="0" marL="0">
+              <a:buNone/>
+            </a:pPr>
+            <a:r>
+              <a:rPr lang="en-US" sz="900" dirty="0">
+                <a:solidFill>
+                  <a:srgbClr val="161616"/>
+                </a:solidFill>
+                <a:latin typeface="IBM Plex Mono" pitchFamily="34" charset="0"/>
+                <a:ea typeface="IBM Plex Mono" pitchFamily="34" charset="-122"/>
+                <a:cs typeface="IBM Plex Mono" pitchFamily="34" charset="-120"/>
+              </a:rPr>
+              <a:t>accounts</a:t>
+            </a:r>
+            <a:endParaRPr lang="en-US" sz="900" dirty="0"/>
+          </a:p>
+        </p:txBody>
+      </p:sp>
+      <p:sp>
+        <p:nvSpPr>
+          <p:cNvPr id="27" name="Shape 25"/>
+          <p:cNvSpPr/>
+          <p:nvPr/>
+        </p:nvSpPr>
+        <p:spPr>
+          <a:xfrm>
+            <a:off x="2990088" y="3264408"/>
+            <a:ext cx="1920240" cy="365760"/>
+          </a:xfrm>
+          <a:prstGeom prst="roundRect">
+            <a:avLst>
+              <a:gd name="adj" fmla="val 12500"/>
+            </a:avLst>
+          </a:prstGeom>
+          <a:solidFill>
+            <a:srgbClr val="FFFFFF"/>
+          </a:solidFill>
+          <a:ln w="9525">
+            <a:solidFill>
+              <a:srgbClr val="D0D0D0"/>
+            </a:solidFill>
+            <a:prstDash val="solid"/>
+          </a:ln>
+        </p:spPr>
+      </p:sp>
+      <p:sp>
+        <p:nvSpPr>
+          <p:cNvPr id="28" name="Text 26"/>
+          <p:cNvSpPr/>
+          <p:nvPr/>
+        </p:nvSpPr>
+        <p:spPr>
+          <a:xfrm>
+            <a:off x="2990088" y="3264408"/>
+            <a:ext cx="1920240" cy="365760"/>
+          </a:xfrm>
+          <a:prstGeom prst="rect">
+            <a:avLst/>
+          </a:prstGeom>
+          <a:noFill/>
+          <a:ln/>
+        </p:spPr>
+        <p:txBody>
+          <a:bodyPr wrap="square" lIns="0" tIns="0" rIns="0" bIns="0" rtlCol="0" anchor="ctr"/>
+          <a:lstStyle/>
+          <a:p>
+            <a:pPr algn="ctr" indent="0" marL="0">
+              <a:buNone/>
+            </a:pPr>
+            <a:r>
+              <a:rPr lang="en-US" sz="900" dirty="0">
+                <a:solidFill>
+                  <a:srgbClr val="161616"/>
+                </a:solidFill>
+                <a:latin typeface="IBM Plex Mono" pitchFamily="34" charset="0"/>
+                <a:ea typeface="IBM Plex Mono" pitchFamily="34" charset="-122"/>
+                <a:cs typeface="IBM Plex Mono" pitchFamily="34" charset="-120"/>
+              </a:rPr>
+              <a:t>deposit</a:t>
+            </a:r>
+            <a:endParaRPr lang="en-US" sz="900" dirty="0"/>
+          </a:p>
+        </p:txBody>
+      </p:sp>
+      <p:sp>
+        <p:nvSpPr>
+          <p:cNvPr id="29" name="Shape 27"/>
+          <p:cNvSpPr/>
+          <p:nvPr/>
+        </p:nvSpPr>
+        <p:spPr>
+          <a:xfrm>
+            <a:off x="5056632" y="3264408"/>
+            <a:ext cx="1920240" cy="365760"/>
+          </a:xfrm>
+          <a:prstGeom prst="roundRect">
+            <a:avLst>
+              <a:gd name="adj" fmla="val 12500"/>
+            </a:avLst>
+          </a:prstGeom>
+          <a:solidFill>
+            <a:srgbClr val="FFFFFF"/>
+          </a:solidFill>
+          <a:ln w="9525">
+            <a:solidFill>
+              <a:srgbClr val="D0D0D0"/>
+            </a:solidFill>
+            <a:prstDash val="solid"/>
+          </a:ln>
+        </p:spPr>
+      </p:sp>
+      <p:sp>
+        <p:nvSpPr>
+          <p:cNvPr id="30" name="Text 28"/>
+          <p:cNvSpPr/>
+          <p:nvPr/>
+        </p:nvSpPr>
+        <p:spPr>
+          <a:xfrm>
+            <a:off x="5056632" y="3264408"/>
+            <a:ext cx="1920240" cy="365760"/>
+          </a:xfrm>
+          <a:prstGeom prst="rect">
+            <a:avLst/>
+          </a:prstGeom>
+          <a:noFill/>
+          <a:ln/>
+        </p:spPr>
+        <p:txBody>
+          <a:bodyPr wrap="square" lIns="0" tIns="0" rIns="0" bIns="0" rtlCol="0" anchor="ctr"/>
+          <a:lstStyle/>
+          <a:p>
+            <a:pPr algn="ctr" indent="0" marL="0">
+              <a:buNone/>
+            </a:pPr>
+            <a:r>
+              <a:rPr lang="en-US" sz="900" dirty="0">
+                <a:solidFill>
+                  <a:srgbClr val="161616"/>
+                </a:solidFill>
+                <a:latin typeface="IBM Plex Mono" pitchFamily="34" charset="0"/>
+                <a:ea typeface="IBM Plex Mono" pitchFamily="34" charset="-122"/>
+                <a:cs typeface="IBM Plex Mono" pitchFamily="34" charset="-120"/>
+              </a:rPr>
+              <a:t>transfer</a:t>
+            </a:r>
+            <a:endParaRPr lang="en-US" sz="900" dirty="0"/>
+          </a:p>
+        </p:txBody>
+      </p:sp>
+      <p:sp>
+        <p:nvSpPr>
+          <p:cNvPr id="31" name="Shape 29"/>
+          <p:cNvSpPr/>
+          <p:nvPr/>
+        </p:nvSpPr>
+        <p:spPr>
+          <a:xfrm>
+            <a:off x="7123176" y="3264408"/>
+            <a:ext cx="1920240" cy="365760"/>
+          </a:xfrm>
+          <a:prstGeom prst="roundRect">
+            <a:avLst>
+              <a:gd name="adj" fmla="val 12500"/>
+            </a:avLst>
+          </a:prstGeom>
+          <a:solidFill>
+            <a:srgbClr val="FFFFFF"/>
+          </a:solidFill>
+          <a:ln w="9525">
+            <a:solidFill>
+              <a:srgbClr val="D0D0D0"/>
+            </a:solidFill>
+            <a:prstDash val="solid"/>
+          </a:ln>
+        </p:spPr>
+      </p:sp>
+      <p:sp>
+        <p:nvSpPr>
+          <p:cNvPr id="32" name="Text 30"/>
+          <p:cNvSpPr/>
+          <p:nvPr/>
+        </p:nvSpPr>
+        <p:spPr>
+          <a:xfrm>
+            <a:off x="7123176" y="3264408"/>
+            <a:ext cx="1920240" cy="365760"/>
+          </a:xfrm>
+          <a:prstGeom prst="rect">
+            <a:avLst/>
+          </a:prstGeom>
+          <a:noFill/>
+          <a:ln/>
+        </p:spPr>
+        <p:txBody>
+          <a:bodyPr wrap="square" lIns="0" tIns="0" rIns="0" bIns="0" rtlCol="0" anchor="ctr"/>
+          <a:lstStyle/>
+          <a:p>
+            <a:pPr algn="ctr" indent="0" marL="0">
+              <a:buNone/>
+            </a:pPr>
+            <a:r>
+              <a:rPr lang="en-US" sz="900" dirty="0">
+                <a:solidFill>
+                  <a:srgbClr val="161616"/>
+                </a:solidFill>
+                <a:latin typeface="IBM Plex Mono" pitchFamily="34" charset="0"/>
+                <a:ea typeface="IBM Plex Mono" pitchFamily="34" charset="-122"/>
+                <a:cs typeface="IBM Plex Mono" pitchFamily="34" charset="-120"/>
+              </a:rPr>
+              <a:t>history</a:t>
+            </a:r>
+            <a:endParaRPr lang="en-US" sz="900" dirty="0"/>
+          </a:p>
+        </p:txBody>
+      </p:sp>
+      <p:sp>
+        <p:nvSpPr>
+          <p:cNvPr id="33" name="Shape 31"/>
+          <p:cNvSpPr/>
+          <p:nvPr/>
+        </p:nvSpPr>
+        <p:spPr>
+          <a:xfrm>
+            <a:off x="9189720" y="3264408"/>
+            <a:ext cx="1920240" cy="365760"/>
+          </a:xfrm>
+          <a:prstGeom prst="roundRect">
+            <a:avLst>
+              <a:gd name="adj" fmla="val 12500"/>
+            </a:avLst>
+          </a:prstGeom>
+          <a:solidFill>
+            <a:srgbClr val="FFFFFF"/>
+          </a:solidFill>
+          <a:ln w="9525">
+            <a:solidFill>
+              <a:srgbClr val="D0D0D0"/>
+            </a:solidFill>
+            <a:prstDash val="solid"/>
+          </a:ln>
+        </p:spPr>
+      </p:sp>
+      <p:sp>
+        <p:nvSpPr>
+          <p:cNvPr id="34" name="Text 32"/>
+          <p:cNvSpPr/>
+          <p:nvPr/>
+        </p:nvSpPr>
+        <p:spPr>
+          <a:xfrm>
+            <a:off x="9189720" y="3264408"/>
+            <a:ext cx="1920240" cy="365760"/>
+          </a:xfrm>
+          <a:prstGeom prst="rect">
+            <a:avLst/>
+          </a:prstGeom>
+          <a:noFill/>
+          <a:ln/>
+        </p:spPr>
+        <p:txBody>
+          <a:bodyPr wrap="square" lIns="0" tIns="0" rIns="0" bIns="0" rtlCol="0" anchor="ctr"/>
+          <a:lstStyle/>
+          <a:p>
+            <a:pPr algn="ctr" indent="0" marL="0">
+              <a:buNone/>
+            </a:pPr>
+            <a:r>
+              <a:rPr lang="en-US" sz="900" dirty="0">
+                <a:solidFill>
+                  <a:srgbClr val="161616"/>
+                </a:solidFill>
+                <a:latin typeface="IBM Plex Mono" pitchFamily="34" charset="0"/>
+                <a:ea typeface="IBM Plex Mono" pitchFamily="34" charset="-122"/>
+                <a:cs typeface="IBM Plex Mono" pitchFamily="34" charset="-120"/>
+              </a:rPr>
+              <a:t>logout</a:t>
+            </a:r>
+            <a:endParaRPr lang="en-US" sz="900" dirty="0"/>
+          </a:p>
+        </p:txBody>
+      </p:sp>
+      <p:sp>
+        <p:nvSpPr>
+          <p:cNvPr id="35" name="Shape 33"/>
+          <p:cNvSpPr/>
+          <p:nvPr/>
+        </p:nvSpPr>
+        <p:spPr>
+          <a:xfrm>
+            <a:off x="2990088" y="3739896"/>
+            <a:ext cx="8119872" cy="384048"/>
+          </a:xfrm>
+          <a:prstGeom prst="roundRect">
+            <a:avLst>
+              <a:gd name="adj" fmla="val 11905"/>
+            </a:avLst>
+          </a:prstGeom>
+          <a:solidFill>
+            <a:srgbClr val="FFF7E6"/>
+          </a:solidFill>
+          <a:ln w="9525">
+            <a:solidFill>
+              <a:srgbClr val="B59000"/>
+            </a:solidFill>
+            <a:prstDash val="dash"/>
+          </a:ln>
+        </p:spPr>
+      </p:sp>
+      <p:sp>
+        <p:nvSpPr>
+          <p:cNvPr id="36" name="Shape 34"/>
+          <p:cNvSpPr/>
+          <p:nvPr/>
+        </p:nvSpPr>
+        <p:spPr>
+          <a:xfrm>
+            <a:off x="3099816" y="3822192"/>
+            <a:ext cx="457200" cy="219456"/>
+          </a:xfrm>
+          <a:prstGeom prst="roundRect">
+            <a:avLst>
+              <a:gd name="adj" fmla="val 50000"/>
+            </a:avLst>
+          </a:prstGeom>
+          <a:solidFill>
+            <a:srgbClr val="FFF0CC"/>
+          </a:solidFill>
+          <a:ln w="6350">
+            <a:solidFill>
+              <a:srgbClr val="9A6A00"/>
+            </a:solidFill>
+            <a:prstDash val="solid"/>
+          </a:ln>
+        </p:spPr>
+      </p:sp>
+      <p:sp>
+        <p:nvSpPr>
+          <p:cNvPr id="37" name="Text 35"/>
+          <p:cNvSpPr/>
+          <p:nvPr/>
+        </p:nvSpPr>
+        <p:spPr>
+          <a:xfrm>
+            <a:off x="3099816" y="3822192"/>
+            <a:ext cx="457200" cy="219456"/>
+          </a:xfrm>
+          <a:prstGeom prst="rect">
+            <a:avLst/>
+          </a:prstGeom>
+          <a:noFill/>
+          <a:ln/>
+        </p:spPr>
+        <p:txBody>
+          <a:bodyPr wrap="square" lIns="0" tIns="0" rIns="0" bIns="0" rtlCol="0" anchor="ctr"/>
+          <a:lstStyle/>
+          <a:p>
+            <a:pPr algn="ctr" indent="0" marL="0">
+              <a:buNone/>
+            </a:pPr>
+            <a:r>
+              <a:rPr lang="en-US" sz="800" b="1" dirty="0">
+                <a:solidFill>
+                  <a:srgbClr val="9A6A00"/>
+                </a:solidFill>
+                <a:latin typeface="IBM Plex Mono" pitchFamily="34" charset="0"/>
+                <a:ea typeface="IBM Plex Mono" pitchFamily="34" charset="-122"/>
+                <a:cs typeface="IBM Plex Mono" pitchFamily="34" charset="-120"/>
+              </a:rPr>
+              <a:t>VM</a:t>
+            </a:r>
+            <a:endParaRPr lang="en-US" sz="800" dirty="0"/>
+          </a:p>
+        </p:txBody>
+      </p:sp>
+      <p:sp>
+        <p:nvSpPr>
+          <p:cNvPr id="38" name="Text 36"/>
+          <p:cNvSpPr/>
+          <p:nvPr/>
+        </p:nvSpPr>
+        <p:spPr>
+          <a:xfrm>
+            <a:off x="3648456" y="3739896"/>
+            <a:ext cx="7388352" cy="384048"/>
+          </a:xfrm>
+          <a:prstGeom prst="rect">
+            <a:avLst/>
+          </a:prstGeom>
+          <a:noFill/>
+          <a:ln/>
+        </p:spPr>
+        <p:txBody>
+          <a:bodyPr wrap="square" lIns="0" tIns="0" rIns="0" bIns="0" rtlCol="0" anchor="ctr"/>
+          <a:lstStyle/>
+          <a:p>
             <a:pPr indent="0" marL="0">
               <a:buNone/>
             </a:pPr>
             <a:r>
-              <a:rPr lang="en-US" sz="4600" dirty="0">
-                <a:solidFill>
-                  <a:srgbClr val="0F62FE"/>
+              <a:rPr lang="en-US" sz="1100" dirty="0">
+                <a:solidFill>
+                  <a:srgbClr val="161616"/>
                 </a:solidFill>
                 <a:latin typeface="IBM Plex Sans" pitchFamily="34" charset="0"/>
                 <a:ea typeface="IBM Plex Sans" pitchFamily="34" charset="-122"/>
                 <a:cs typeface="IBM Plex Sans" pitchFamily="34" charset="-120"/>
               </a:rPr>
-              <a:t>8</a:t>
-            </a:r>
-            <a:pPr indent="0" marL="0">
-              <a:buNone/>
-            </a:pPr>
-            <a:r>
-              <a:rPr lang="en-US" sz="1800" dirty="0">
-                <a:solidFill>
-                  <a:srgbClr val="525252"/>
+              <a:t>EDB Advanced — banco PostgreSQL rodando em VM</a:t>
+            </a:r>
+            <a:endParaRPr lang="en-US" sz="1100" dirty="0"/>
+          </a:p>
+        </p:txBody>
+      </p:sp>
+      <p:sp>
+        <p:nvSpPr>
+          <p:cNvPr id="39" name="Text 37"/>
+          <p:cNvSpPr/>
+          <p:nvPr/>
+        </p:nvSpPr>
+        <p:spPr>
+          <a:xfrm>
+            <a:off x="3794760" y="4572000"/>
+            <a:ext cx="1645920" cy="640080"/>
+          </a:xfrm>
+          <a:prstGeom prst="rect">
+            <a:avLst/>
+          </a:prstGeom>
+          <a:noFill/>
+          <a:ln/>
+        </p:spPr>
+        <p:txBody>
+          <a:bodyPr wrap="square" lIns="0" tIns="0" rIns="0" bIns="0" rtlCol="0" anchor="ctr"/>
+          <a:lstStyle/>
+          <a:p>
+            <a:pPr algn="ctr" indent="0" marL="0">
+              <a:buNone/>
+            </a:pPr>
+            <a:r>
+              <a:rPr lang="en-US" sz="4200" dirty="0">
+                <a:solidFill>
+                  <a:srgbClr val="8D8D8D"/>
                 </a:solidFill>
                 <a:latin typeface="IBM Plex Sans" pitchFamily="34" charset="0"/>
                 <a:ea typeface="IBM Plex Sans" pitchFamily="34" charset="-122"/>
                 <a:cs typeface="IBM Plex Sans" pitchFamily="34" charset="-120"/>
               </a:rPr>
-              <a:t> IFLs</a:t>
-            </a:r>
-            <a:endParaRPr lang="en-US" sz="4600" dirty="0"/>
-          </a:p>
-        </p:txBody>
-      </p:sp>
-      <p:sp>
-        <p:nvSpPr>
-          <p:cNvPr id="17" name="Shape 15"/>
-          <p:cNvSpPr/>
-          <p:nvPr/>
-        </p:nvSpPr>
-        <p:spPr>
-          <a:xfrm>
-            <a:off x="6812280" y="4187952"/>
-            <a:ext cx="91440" cy="91440"/>
-          </a:xfrm>
-          <a:prstGeom prst="ellipse">
-            <a:avLst/>
-          </a:prstGeom>
-          <a:solidFill>
-            <a:srgbClr val="0F62FE"/>
-          </a:solidFill>
-          <a:ln/>
-        </p:spPr>
-      </p:sp>
-      <p:sp>
-        <p:nvSpPr>
-          <p:cNvPr id="18" name="Text 16"/>
-          <p:cNvSpPr/>
-          <p:nvPr/>
-        </p:nvSpPr>
-        <p:spPr>
-          <a:xfrm>
-            <a:off x="7040880" y="4114800"/>
-            <a:ext cx="3749040" cy="384048"/>
-          </a:xfrm>
-          <a:prstGeom prst="rect">
-            <a:avLst/>
-          </a:prstGeom>
-          <a:noFill/>
-          <a:ln/>
-        </p:spPr>
-        <p:txBody>
-          <a:bodyPr wrap="square" lIns="0" tIns="0" rIns="0" bIns="0" rtlCol="0" anchor="t"/>
-          <a:lstStyle/>
-          <a:p>
-            <a:pPr indent="0" marL="0">
-              <a:lnSpc>
-                <a:spcPct val="110000"/>
-              </a:lnSpc>
-              <a:buNone/>
-            </a:pPr>
-            <a:r>
-              <a:rPr lang="en-US" sz="1300" dirty="0">
-                <a:solidFill>
-                  <a:srgbClr val="161616"/>
-                </a:solidFill>
-                <a:latin typeface="IBM Plex Sans" pitchFamily="34" charset="0"/>
-                <a:ea typeface="IBM Plex Sans" pitchFamily="34" charset="-122"/>
-                <a:cs typeface="IBM Plex Sans" pitchFamily="34" charset="-120"/>
-              </a:rPr>
-              <a:t>1 LPAR no IBM LinuxONE</a:t>
-            </a:r>
-            <a:endParaRPr lang="en-US" sz="1300" dirty="0"/>
-          </a:p>
-        </p:txBody>
-      </p:sp>
-      <p:sp>
-        <p:nvSpPr>
-          <p:cNvPr id="19" name="Shape 17"/>
-          <p:cNvSpPr/>
-          <p:nvPr/>
-        </p:nvSpPr>
-        <p:spPr>
-          <a:xfrm>
-            <a:off x="6812280" y="4608576"/>
-            <a:ext cx="91440" cy="91440"/>
-          </a:xfrm>
-          <a:prstGeom prst="ellipse">
-            <a:avLst/>
-          </a:prstGeom>
-          <a:solidFill>
-            <a:srgbClr val="0F62FE"/>
-          </a:solidFill>
-          <a:ln/>
-        </p:spPr>
-      </p:sp>
-      <p:sp>
-        <p:nvSpPr>
-          <p:cNvPr id="20" name="Text 18"/>
-          <p:cNvSpPr/>
-          <p:nvPr/>
-        </p:nvSpPr>
-        <p:spPr>
-          <a:xfrm>
-            <a:off x="7040880" y="4535424"/>
-            <a:ext cx="3749040" cy="384048"/>
-          </a:xfrm>
-          <a:prstGeom prst="rect">
-            <a:avLst/>
-          </a:prstGeom>
-          <a:noFill/>
-          <a:ln/>
-        </p:spPr>
-        <p:txBody>
-          <a:bodyPr wrap="square" lIns="0" tIns="0" rIns="0" bIns="0" rtlCol="0" anchor="t"/>
-          <a:lstStyle/>
-          <a:p>
-            <a:pPr indent="0" marL="0">
-              <a:lnSpc>
-                <a:spcPct val="110000"/>
-              </a:lnSpc>
-              <a:buNone/>
-            </a:pPr>
-            <a:r>
-              <a:rPr lang="en-US" sz="1300" dirty="0">
-                <a:solidFill>
-                  <a:srgbClr val="161616"/>
-                </a:solidFill>
-                <a:latin typeface="IBM Plex Sans" pitchFamily="34" charset="0"/>
-                <a:ea typeface="IBM Plex Sans" pitchFamily="34" charset="-122"/>
-                <a:cs typeface="IBM Plex Sans" pitchFamily="34" charset="-120"/>
-              </a:rPr>
-              <a:t>Mesma carga em Red Hat OpenShift Virtualization</a:t>
-            </a:r>
-            <a:endParaRPr lang="en-US" sz="1300" dirty="0"/>
-          </a:p>
-        </p:txBody>
-      </p:sp>
-      <p:sp>
-        <p:nvSpPr>
-          <p:cNvPr id="21" name="Shape 19"/>
-          <p:cNvSpPr/>
-          <p:nvPr/>
-        </p:nvSpPr>
-        <p:spPr>
-          <a:xfrm>
-            <a:off x="6812280" y="5029200"/>
-            <a:ext cx="91440" cy="91440"/>
-          </a:xfrm>
-          <a:prstGeom prst="ellipse">
-            <a:avLst/>
-          </a:prstGeom>
-          <a:solidFill>
-            <a:srgbClr val="0F62FE"/>
-          </a:solidFill>
-          <a:ln/>
-        </p:spPr>
-      </p:sp>
-      <p:sp>
-        <p:nvSpPr>
-          <p:cNvPr id="22" name="Text 20"/>
-          <p:cNvSpPr/>
-          <p:nvPr/>
-        </p:nvSpPr>
-        <p:spPr>
-          <a:xfrm>
-            <a:off x="7040880" y="4956048"/>
-            <a:ext cx="3749040" cy="384048"/>
-          </a:xfrm>
-          <a:prstGeom prst="rect">
-            <a:avLst/>
-          </a:prstGeom>
-          <a:noFill/>
-          <a:ln/>
-        </p:spPr>
-        <p:txBody>
-          <a:bodyPr wrap="square" lIns="0" tIns="0" rIns="0" bIns="0" rtlCol="0" anchor="t"/>
-          <a:lstStyle/>
-          <a:p>
-            <a:pPr indent="0" marL="0">
-              <a:lnSpc>
-                <a:spcPct val="110000"/>
-              </a:lnSpc>
-              <a:buNone/>
-            </a:pPr>
-            <a:r>
-              <a:rPr lang="en-US" sz="1300" dirty="0">
-                <a:solidFill>
-                  <a:srgbClr val="161616"/>
-                </a:solidFill>
-                <a:latin typeface="IBM Plex Sans" pitchFamily="34" charset="0"/>
-                <a:ea typeface="IBM Plex Sans" pitchFamily="34" charset="-122"/>
-                <a:cs typeface="IBM Plex Sans" pitchFamily="34" charset="-120"/>
-              </a:rPr>
-              <a:t>VMs e containers no mesmo cluster</a:t>
-            </a:r>
-            <a:endParaRPr lang="en-US" sz="1300" dirty="0"/>
-          </a:p>
-        </p:txBody>
-      </p:sp>
-      <p:sp>
-        <p:nvSpPr>
-          <p:cNvPr id="23" name="Text 21"/>
-          <p:cNvSpPr/>
-          <p:nvPr/>
-        </p:nvSpPr>
-        <p:spPr>
-          <a:xfrm>
-            <a:off x="5577840" y="3547872"/>
-            <a:ext cx="822960" cy="274320"/>
+              <a:t>224</a:t>
+            </a:r>
+            <a:endParaRPr lang="en-US" sz="4200" dirty="0"/>
+          </a:p>
+        </p:txBody>
+      </p:sp>
+      <p:sp>
+        <p:nvSpPr>
+          <p:cNvPr id="40" name="Text 38"/>
+          <p:cNvSpPr/>
+          <p:nvPr/>
+        </p:nvSpPr>
+        <p:spPr>
+          <a:xfrm>
+            <a:off x="3337560" y="5248656"/>
+            <a:ext cx="2560320" cy="274320"/>
           </a:xfrm>
           <a:prstGeom prst="rect">
             <a:avLst/>
@@ -12230,36 +12812,75 @@
               <a:buNone/>
             </a:pPr>
             <a:r>
-              <a:rPr lang="en-US" sz="1400" b="1" dirty="0">
-                <a:solidFill>
-                  <a:srgbClr val="0F62FE"/>
+              <a:rPr lang="en-US" sz="950" dirty="0">
+                <a:solidFill>
+                  <a:srgbClr val="525252"/>
                 </a:solidFill>
                 <a:latin typeface="IBM Plex Mono" pitchFamily="34" charset="0"/>
                 <a:ea typeface="IBM Plex Mono" pitchFamily="34" charset="-122"/>
                 <a:cs typeface="IBM Plex Mono" pitchFamily="34" charset="-120"/>
               </a:rPr>
+              <a:t>cores x86 · 5 servidores</a:t>
+            </a:r>
+            <a:endParaRPr lang="en-US" sz="950" dirty="0"/>
+          </a:p>
+        </p:txBody>
+      </p:sp>
+      <p:sp>
+        <p:nvSpPr>
+          <p:cNvPr id="41" name="Text 39"/>
+          <p:cNvSpPr/>
+          <p:nvPr/>
+        </p:nvSpPr>
+        <p:spPr>
+          <a:xfrm>
+            <a:off x="5532120" y="4608576"/>
+            <a:ext cx="1005840" cy="274320"/>
+          </a:xfrm>
+          <a:prstGeom prst="rect">
+            <a:avLst/>
+          </a:prstGeom>
+          <a:noFill/>
+          <a:ln/>
+        </p:spPr>
+        <p:txBody>
+          <a:bodyPr wrap="square" lIns="0" tIns="0" rIns="0" bIns="0" rtlCol="0" anchor="ctr"/>
+          <a:lstStyle/>
+          <a:p>
+            <a:pPr algn="ctr" indent="0" marL="0">
+              <a:buNone/>
+            </a:pPr>
+            <a:r>
+              <a:rPr lang="en-US" sz="1300" b="1" dirty="0">
+                <a:solidFill>
+                  <a:srgbClr val="0F62FE"/>
+                </a:solidFill>
+                <a:latin typeface="IBM Plex Mono" pitchFamily="34" charset="0"/>
+                <a:ea typeface="IBM Plex Mono" pitchFamily="34" charset="-122"/>
+                <a:cs typeface="IBM Plex Mono" pitchFamily="34" charset="-120"/>
+              </a:rPr>
               <a:t>÷28</a:t>
             </a:r>
-            <a:endParaRPr lang="en-US" sz="1400" dirty="0"/>
-          </a:p>
-        </p:txBody>
-      </p:sp>
-      <p:sp>
-        <p:nvSpPr>
-          <p:cNvPr id="24" name="Shape 22"/>
-          <p:cNvSpPr/>
-          <p:nvPr/>
-        </p:nvSpPr>
-        <p:spPr>
-          <a:xfrm>
-            <a:off x="5687568" y="3931920"/>
-            <a:ext cx="603504" cy="0"/>
+            <a:endParaRPr lang="en-US" sz="1300" dirty="0"/>
+          </a:p>
+        </p:txBody>
+      </p:sp>
+      <p:sp>
+        <p:nvSpPr>
+          <p:cNvPr id="42" name="Shape 40"/>
+          <p:cNvSpPr/>
+          <p:nvPr/>
+        </p:nvSpPr>
+        <p:spPr>
+          <a:xfrm>
+            <a:off x="5623560" y="4983480"/>
+            <a:ext cx="822960" cy="0"/>
           </a:xfrm>
           <a:prstGeom prst="line">
             <a:avLst/>
           </a:prstGeom>
           <a:noFill/>
-          <a:ln w="38100">
+          <a:ln w="31750">
             <a:solidFill>
               <a:srgbClr val="0F62FE"/>
             </a:solidFill>
@@ -12270,14 +12891,14 @@
       </p:sp>
       <p:sp>
         <p:nvSpPr>
-          <p:cNvPr id="25" name="Text 23"/>
-          <p:cNvSpPr/>
-          <p:nvPr/>
-        </p:nvSpPr>
-        <p:spPr>
-          <a:xfrm>
-            <a:off x="5577840" y="4041648"/>
-            <a:ext cx="822960" cy="274320"/>
+          <p:cNvPr id="43" name="Text 41"/>
+          <p:cNvSpPr/>
+          <p:nvPr/>
+        </p:nvSpPr>
+        <p:spPr>
+          <a:xfrm>
+            <a:off x="6629400" y="4572000"/>
+            <a:ext cx="1645920" cy="640080"/>
           </a:xfrm>
           <a:prstGeom prst="rect">
             <a:avLst/>
@@ -12293,7 +12914,46 @@
               <a:buNone/>
             </a:pPr>
             <a:r>
-              <a:rPr lang="en-US" sz="900" dirty="0">
+              <a:rPr lang="en-US" sz="4200" dirty="0">
+                <a:solidFill>
+                  <a:srgbClr val="0F62FE"/>
+                </a:solidFill>
+                <a:latin typeface="IBM Plex Sans" pitchFamily="34" charset="0"/>
+                <a:ea typeface="IBM Plex Sans" pitchFamily="34" charset="-122"/>
+                <a:cs typeface="IBM Plex Sans" pitchFamily="34" charset="-120"/>
+              </a:rPr>
+              <a:t>8</a:t>
+            </a:r>
+            <a:endParaRPr lang="en-US" sz="4200" dirty="0"/>
+          </a:p>
+        </p:txBody>
+      </p:sp>
+      <p:sp>
+        <p:nvSpPr>
+          <p:cNvPr id="44" name="Text 42"/>
+          <p:cNvSpPr/>
+          <p:nvPr/>
+        </p:nvSpPr>
+        <p:spPr>
+          <a:xfrm>
+            <a:off x="6263640" y="5248656"/>
+            <a:ext cx="2377440" cy="274320"/>
+          </a:xfrm>
+          <a:prstGeom prst="rect">
+            <a:avLst/>
+          </a:prstGeom>
+          <a:noFill/>
+          <a:ln/>
+        </p:spPr>
+        <p:txBody>
+          <a:bodyPr wrap="square" lIns="0" tIns="0" rIns="0" bIns="0" rtlCol="0" anchor="ctr"/>
+          <a:lstStyle/>
+          <a:p>
+            <a:pPr algn="ctr" indent="0" marL="0">
+              <a:buNone/>
+            </a:pPr>
+            <a:r>
+              <a:rPr lang="en-US" sz="950" dirty="0">
                 <a:solidFill>
                   <a:srgbClr val="525252"/>
                 </a:solidFill>
@@ -12301,104 +12961,9 @@
                 <a:ea typeface="IBM Plex Mono" pitchFamily="34" charset="-122"/>
                 <a:cs typeface="IBM Plex Mono" pitchFamily="34" charset="-120"/>
               </a:rPr>
-              <a:t>cores</a:t>
-            </a:r>
-            <a:endParaRPr lang="en-US" sz="900" dirty="0"/>
-          </a:p>
-        </p:txBody>
-      </p:sp>
-      <p:sp>
-        <p:nvSpPr>
-          <p:cNvPr id="26" name="Text 24"/>
-          <p:cNvSpPr/>
-          <p:nvPr/>
-        </p:nvSpPr>
-        <p:spPr>
-          <a:xfrm>
-            <a:off x="822960" y="5760720"/>
-            <a:ext cx="10515600" cy="365760"/>
-          </a:xfrm>
-          <a:prstGeom prst="rect">
-            <a:avLst/>
-          </a:prstGeom>
-          <a:noFill/>
-          <a:ln/>
-        </p:spPr>
-        <p:txBody>
-          <a:bodyPr wrap="square" lIns="0" tIns="0" rIns="0" bIns="0" rtlCol="0" anchor="ctr"/>
-          <a:lstStyle/>
-          <a:p>
-            <a:pPr algn="ctr" indent="0" marL="0">
-              <a:buNone/>
-            </a:pPr>
-            <a:r>
-              <a:rPr lang="en-US" sz="1300" dirty="0">
-                <a:solidFill>
-                  <a:srgbClr val="525252"/>
-                </a:solidFill>
-                <a:latin typeface="IBM Plex Sans" pitchFamily="34" charset="0"/>
-                <a:ea typeface="IBM Plex Sans" pitchFamily="34" charset="-122"/>
-                <a:cs typeface="IBM Plex Sans" pitchFamily="34" charset="-120"/>
-              </a:rPr>
-              <a:t>Aplicação </a:t>
-            </a:r>
-            <a:pPr algn="ctr" indent="0" marL="0">
-              <a:buNone/>
-            </a:pPr>
-            <a:r>
-              <a:rPr lang="en-US" sz="1300" b="1" dirty="0">
-                <a:solidFill>
-                  <a:srgbClr val="161616"/>
-                </a:solidFill>
-                <a:latin typeface="IBM Plex Sans" pitchFamily="34" charset="0"/>
-                <a:ea typeface="IBM Plex Sans" pitchFamily="34" charset="-122"/>
-                <a:cs typeface="IBM Plex Sans" pitchFamily="34" charset="-120"/>
-              </a:rPr>
-              <a:t>EnterpriseDB</a:t>
-            </a:r>
-            <a:pPr algn="ctr" indent="0" marL="0">
-              <a:buNone/>
-            </a:pPr>
-            <a:r>
-              <a:rPr lang="en-US" sz="1300" dirty="0">
-                <a:solidFill>
-                  <a:srgbClr val="525252"/>
-                </a:solidFill>
-                <a:latin typeface="IBM Plex Sans" pitchFamily="34" charset="0"/>
-                <a:ea typeface="IBM Plex Sans" pitchFamily="34" charset="-122"/>
-                <a:cs typeface="IBM Plex Sans" pitchFamily="34" charset="-120"/>
-              </a:rPr>
-              <a:t> sob carga (</a:t>
-            </a:r>
-            <a:pPr algn="ctr" indent="0" marL="0">
-              <a:buNone/>
-            </a:pPr>
-            <a:r>
-              <a:rPr lang="en-US" sz="1300" b="1" dirty="0">
-                <a:solidFill>
-                  <a:srgbClr val="161616"/>
-                </a:solidFill>
-                <a:latin typeface="IBM Plex Sans" pitchFamily="34" charset="0"/>
-                <a:ea typeface="IBM Plex Sans" pitchFamily="34" charset="-122"/>
-                <a:cs typeface="IBM Plex Sans" pitchFamily="34" charset="-120"/>
-              </a:rPr>
-              <a:t>k6</a:t>
-            </a:r>
-            <a:pPr algn="ctr" indent="0" marL="0">
-              <a:buNone/>
-            </a:pPr>
-            <a:r>
-              <a:rPr lang="en-US" sz="1300" dirty="0">
-                <a:solidFill>
-                  <a:srgbClr val="525252"/>
-                </a:solidFill>
-                <a:latin typeface="IBM Plex Sans" pitchFamily="34" charset="0"/>
-                <a:ea typeface="IBM Plex Sans" pitchFamily="34" charset="-122"/>
-                <a:cs typeface="IBM Plex Sans" pitchFamily="34" charset="-120"/>
-              </a:rPr>
-              <a:t>) — mesma carga de trabalho nos dois ambientes</a:t>
-            </a:r>
-            <a:endParaRPr lang="en-US" sz="1300" dirty="0"/>
+              <a:t>IFLs · 1 LPAR LinuxONE</a:t>
+            </a:r>
+            <a:endParaRPr lang="en-US" sz="950" dirty="0"/>
           </a:p>
         </p:txBody>
       </p:sp>

</xml_diff>